<commit_message>
Update labs to new structure (Lab00-11), add Outlook/Teams, appendices, capstone, and switch to light theme
</commit_message>
<xml_diff>
--- a/docs/assets/12_Mock_Leadership_Briefing_Source_Deck.pptx
+++ b/docs/assets/12_Mock_Leadership_Briefing_Source_Deck.pptx
@@ -4,6 +4,9 @@
   <p:sldMasterIdLst>
     <p:sldMasterId id="2147483648" r:id="rId1"/>
   </p:sldMasterIdLst>
+  <p:notesMasterIdLst>
+    <p:notesMasterId r:id="rId7"/>
+  </p:notesMasterIdLst>
   <p:sldIdLst>
     <p:sldId id="256" r:id="rId2"/>
     <p:sldId id="257" r:id="rId3"/>
@@ -11,9 +14,6 @@
     <p:sldId id="259" r:id="rId5"/>
     <p:sldId id="260" r:id="rId6"/>
   </p:sldIdLst>
-  <p:notesMasterIdLst>
-    <p:notesMasterId r:id="rId7"/>
-  </p:notesMasterIdLst>
   <p:sldSz cx="12192000" cy="6858000"/>
   <p:notesSz cx="6858000" cy="12192000"/>
   <p:defaultTextStyle>
@@ -108,7 +108,141 @@
       </a:defRPr>
     </a:lvl9pPr>
   </p:defaultTextStyle>
+  <p:extLst>
+    <p:ext uri="{EFAFB233-063F-42B5-8137-9DF3F51BA10A}">
+      <p15:sldGuideLst xmlns:p15="http://schemas.microsoft.com/office/powerpoint/2012/main"/>
+    </p:ext>
+  </p:extLst>
 </p:presentation>
+</file>
+
+<file path=ppt/revisionInfo.xml><?xml version="1.0" encoding="utf-8"?>
+<p1510:revInfo xmlns:a="http://schemas.openxmlformats.org/drawingml/2006/main" xmlns:r="http://schemas.openxmlformats.org/officeDocument/2006/relationships" xmlns:p1510="http://schemas.microsoft.com/office/powerpoint/2015/10/main">
+  <p1510:revLst>
+    <p1510:client id="{79FD8CAE-B805-443E-BA6F-F697070AA191}" v="1" dt="2026-07-23T06:35:06.296"/>
+  </p1510:revLst>
+</p1510:revInfo>
+</file>
+
+<file path=ppt/changesInfos/changesInfo1.xml><?xml version="1.0" encoding="utf-8"?>
+<pc:chgInfo xmlns:a="http://schemas.openxmlformats.org/drawingml/2006/main" xmlns:r="http://schemas.openxmlformats.org/officeDocument/2006/relationships" xmlns:ac="http://schemas.microsoft.com/office/drawing/2013/main/command" xmlns:pc="http://schemas.microsoft.com/office/powerpoint/2013/main/command">
+  <pc:docChgLst>
+    <pc:chgData name="Wilson Tsui" userId="S::wilson.tsui@dsigncodehub.com::04e8895f-245a-4920-a64b-784763c940c9" providerId="AD" clId="Web-{2F6907B7-941F-48BC-AB50-F4E4470A3837}"/>
+    <pc:docChg chg="modSld">
+      <pc:chgData name="Wilson Tsui" userId="S::wilson.tsui@dsigncodehub.com::04e8895f-245a-4920-a64b-784763c940c9" providerId="AD" clId="Web-{2F6907B7-941F-48BC-AB50-F4E4470A3837}" dt="2026-07-23T05:12:19.910" v="0"/>
+      <pc:docMkLst>
+        <pc:docMk/>
+      </pc:docMkLst>
+      <pc:sldChg chg="modSp modNotes">
+        <pc:chgData name="Wilson Tsui" userId="S::wilson.tsui@dsigncodehub.com::04e8895f-245a-4920-a64b-784763c940c9" providerId="AD" clId="Web-{2F6907B7-941F-48BC-AB50-F4E4470A3837}" dt="2026-07-23T05:12:19.910" v="0"/>
+        <pc:sldMkLst>
+          <pc:docMk/>
+          <pc:sldMk cId="0" sldId="256"/>
+        </pc:sldMkLst>
+        <pc:spChg chg="mod">
+          <ac:chgData name="Wilson Tsui" userId="S::wilson.tsui@dsigncodehub.com::04e8895f-245a-4920-a64b-784763c940c9" providerId="AD" clId="Web-{2F6907B7-941F-48BC-AB50-F4E4470A3837}" dt="2026-07-23T05:12:19.910" v="0"/>
+          <ac:spMkLst>
+            <pc:docMk/>
+            <pc:sldMk cId="0" sldId="256"/>
+            <ac:spMk id="14" creationId="{00000000-0000-0000-0000-000000000000}"/>
+          </ac:spMkLst>
+        </pc:spChg>
+        <pc:spChg chg="mod">
+          <ac:chgData name="Wilson Tsui" userId="S::wilson.tsui@dsigncodehub.com::04e8895f-245a-4920-a64b-784763c940c9" providerId="AD" clId="Web-{2F6907B7-941F-48BC-AB50-F4E4470A3837}" dt="2026-07-23T05:12:19.910" v="0"/>
+          <ac:spMkLst>
+            <pc:docMk/>
+            <pc:sldMk cId="0" sldId="256"/>
+            <ac:spMk id="16" creationId="{00000000-0000-0000-0000-000000000000}"/>
+          </ac:spMkLst>
+        </pc:spChg>
+      </pc:sldChg>
+      <pc:sldChg chg="modSp">
+        <pc:chgData name="Wilson Tsui" userId="S::wilson.tsui@dsigncodehub.com::04e8895f-245a-4920-a64b-784763c940c9" providerId="AD" clId="Web-{2F6907B7-941F-48BC-AB50-F4E4470A3837}" dt="2026-07-23T05:12:19.910" v="0"/>
+        <pc:sldMkLst>
+          <pc:docMk/>
+          <pc:sldMk cId="0" sldId="257"/>
+        </pc:sldMkLst>
+        <pc:spChg chg="mod">
+          <ac:chgData name="Wilson Tsui" userId="S::wilson.tsui@dsigncodehub.com::04e8895f-245a-4920-a64b-784763c940c9" providerId="AD" clId="Web-{2F6907B7-941F-48BC-AB50-F4E4470A3837}" dt="2026-07-23T05:12:19.910" v="0"/>
+          <ac:spMkLst>
+            <pc:docMk/>
+            <pc:sldMk cId="0" sldId="257"/>
+            <ac:spMk id="18" creationId="{00000000-0000-0000-0000-000000000000}"/>
+          </ac:spMkLst>
+        </pc:spChg>
+      </pc:sldChg>
+      <pc:sldChg chg="modSp">
+        <pc:chgData name="Wilson Tsui" userId="S::wilson.tsui@dsigncodehub.com::04e8895f-245a-4920-a64b-784763c940c9" providerId="AD" clId="Web-{2F6907B7-941F-48BC-AB50-F4E4470A3837}" dt="2026-07-23T05:12:19.910" v="0"/>
+        <pc:sldMkLst>
+          <pc:docMk/>
+          <pc:sldMk cId="0" sldId="258"/>
+        </pc:sldMkLst>
+        <pc:spChg chg="mod">
+          <ac:chgData name="Wilson Tsui" userId="S::wilson.tsui@dsigncodehub.com::04e8895f-245a-4920-a64b-784763c940c9" providerId="AD" clId="Web-{2F6907B7-941F-48BC-AB50-F4E4470A3837}" dt="2026-07-23T05:12:19.910" v="0"/>
+          <ac:spMkLst>
+            <pc:docMk/>
+            <pc:sldMk cId="0" sldId="258"/>
+            <ac:spMk id="6" creationId="{00000000-0000-0000-0000-000000000000}"/>
+          </ac:spMkLst>
+        </pc:spChg>
+      </pc:sldChg>
+      <pc:sldChg chg="modSp">
+        <pc:chgData name="Wilson Tsui" userId="S::wilson.tsui@dsigncodehub.com::04e8895f-245a-4920-a64b-784763c940c9" providerId="AD" clId="Web-{2F6907B7-941F-48BC-AB50-F4E4470A3837}" dt="2026-07-23T05:12:19.910" v="0"/>
+        <pc:sldMkLst>
+          <pc:docMk/>
+          <pc:sldMk cId="0" sldId="259"/>
+        </pc:sldMkLst>
+        <pc:spChg chg="mod">
+          <ac:chgData name="Wilson Tsui" userId="S::wilson.tsui@dsigncodehub.com::04e8895f-245a-4920-a64b-784763c940c9" providerId="AD" clId="Web-{2F6907B7-941F-48BC-AB50-F4E4470A3837}" dt="2026-07-23T05:12:19.910" v="0"/>
+          <ac:spMkLst>
+            <pc:docMk/>
+            <pc:sldMk cId="0" sldId="259"/>
+            <ac:spMk id="15" creationId="{00000000-0000-0000-0000-000000000000}"/>
+          </ac:spMkLst>
+        </pc:spChg>
+      </pc:sldChg>
+      <pc:sldChg chg="modSp">
+        <pc:chgData name="Wilson Tsui" userId="S::wilson.tsui@dsigncodehub.com::04e8895f-245a-4920-a64b-784763c940c9" providerId="AD" clId="Web-{2F6907B7-941F-48BC-AB50-F4E4470A3837}" dt="2026-07-23T05:12:19.910" v="0"/>
+        <pc:sldMkLst>
+          <pc:docMk/>
+          <pc:sldMk cId="0" sldId="260"/>
+        </pc:sldMkLst>
+        <pc:spChg chg="mod">
+          <ac:chgData name="Wilson Tsui" userId="S::wilson.tsui@dsigncodehub.com::04e8895f-245a-4920-a64b-784763c940c9" providerId="AD" clId="Web-{2F6907B7-941F-48BC-AB50-F4E4470A3837}" dt="2026-07-23T05:12:19.910" v="0"/>
+          <ac:spMkLst>
+            <pc:docMk/>
+            <pc:sldMk cId="0" sldId="260"/>
+            <ac:spMk id="6" creationId="{00000000-0000-0000-0000-000000000000}"/>
+          </ac:spMkLst>
+        </pc:spChg>
+      </pc:sldChg>
+    </pc:docChg>
+  </pc:docChgLst>
+  <pc:docChgLst>
+    <pc:chgData name="Wilson Tsui" userId="S::wilson.tsui@dsigncodehub.com::04e8895f-245a-4920-a64b-784763c940c9" providerId="AD" clId="Web-{79FD8CAE-B805-443E-BA6F-F697070AA191}"/>
+    <pc:docChg chg="modSld">
+      <pc:chgData name="Wilson Tsui" userId="S::wilson.tsui@dsigncodehub.com::04e8895f-245a-4920-a64b-784763c940c9" providerId="AD" clId="Web-{79FD8CAE-B805-443E-BA6F-F697070AA191}" dt="2026-07-23T06:35:06.296" v="0" actId="1076"/>
+      <pc:docMkLst>
+        <pc:docMk/>
+      </pc:docMkLst>
+      <pc:sldChg chg="modSp">
+        <pc:chgData name="Wilson Tsui" userId="S::wilson.tsui@dsigncodehub.com::04e8895f-245a-4920-a64b-784763c940c9" providerId="AD" clId="Web-{79FD8CAE-B805-443E-BA6F-F697070AA191}" dt="2026-07-23T06:35:06.296" v="0" actId="1076"/>
+        <pc:sldMkLst>
+          <pc:docMk/>
+          <pc:sldMk cId="0" sldId="256"/>
+        </pc:sldMkLst>
+        <pc:spChg chg="mod">
+          <ac:chgData name="Wilson Tsui" userId="S::wilson.tsui@dsigncodehub.com::04e8895f-245a-4920-a64b-784763c940c9" providerId="AD" clId="Web-{79FD8CAE-B805-443E-BA6F-F697070AA191}" dt="2026-07-23T06:35:06.296" v="0" actId="1076"/>
+          <ac:spMkLst>
+            <pc:docMk/>
+            <pc:sldMk cId="0" sldId="256"/>
+            <ac:spMk id="5" creationId="{00000000-0000-0000-0000-000000000000}"/>
+          </ac:spMkLst>
+        </pc:spChg>
+      </pc:sldChg>
+    </pc:docChg>
+  </pc:docChgLst>
+</pc:chgInfo>
 </file>
 
 <file path=ppt/notesMasters/notesMaster1.xml><?xml version="1.0" encoding="utf-8"?>
@@ -146,7 +280,7 @@
         <p:spPr>
           <a:xfrm>
             <a:off x="0" y="0"/>
-            <a:ext cx="2971800" cy="458788"/>
+            <a:ext cx="2971800" cy="611188"/>
           </a:xfrm>
           <a:prstGeom prst="rect">
             <a:avLst/>
@@ -177,7 +311,7 @@
         <p:spPr>
           <a:xfrm>
             <a:off x="3884613" y="0"/>
-            <a:ext cx="2971800" cy="458788"/>
+            <a:ext cx="2971800" cy="611188"/>
           </a:xfrm>
           <a:prstGeom prst="rect">
             <a:avLst/>
@@ -191,9 +325,8 @@
             </a:lvl1pPr>
           </a:lstStyle>
           <a:p>
-            <a:fld id="{5282F153-3F37-0F45-9E97-73ACFA13230C}" type="datetimeFigureOut">
-              <a:rPr lang="en-US"/>
-              <a:t>7/23/19</a:t>
+            <a:fld id="{DCE381ED-844C-41ED-88ED-36DD774C43D9}" type="datetimeFigureOut">
+              <a:t>7/22/2026</a:t>
             </a:fld>
             <a:endParaRPr lang="en-US"/>
           </a:p>
@@ -211,8 +344,8 @@
         </p:nvSpPr>
         <p:spPr>
           <a:xfrm>
-            <a:off x="685800" y="1143000"/>
-            <a:ext cx="5486400" cy="3086100"/>
+            <a:off x="-228600" y="1524000"/>
+            <a:ext cx="7315200" cy="4114800"/>
           </a:xfrm>
           <a:prstGeom prst="rect">
             <a:avLst/>
@@ -244,8 +377,8 @@
         </p:nvSpPr>
         <p:spPr>
           <a:xfrm>
-            <a:off x="685800" y="4400550"/>
-            <a:ext cx="5486400" cy="3600450"/>
+            <a:off x="685800" y="5867400"/>
+            <a:ext cx="5486400" cy="4800600"/>
           </a:xfrm>
           <a:prstGeom prst="rect">
             <a:avLst/>
@@ -303,8 +436,8 @@
         </p:nvSpPr>
         <p:spPr>
           <a:xfrm>
-            <a:off x="0" y="8685213"/>
-            <a:ext cx="2971800" cy="458787"/>
+            <a:off x="0" y="11580813"/>
+            <a:ext cx="2971800" cy="611187"/>
           </a:xfrm>
           <a:prstGeom prst="rect">
             <a:avLst/>
@@ -334,8 +467,8 @@
         </p:nvSpPr>
         <p:spPr>
           <a:xfrm>
-            <a:off x="3884613" y="8685213"/>
-            <a:ext cx="2971800" cy="458787"/>
+            <a:off x="3884613" y="11580813"/>
+            <a:ext cx="2971800" cy="611187"/>
           </a:xfrm>
           <a:prstGeom prst="rect">
             <a:avLst/>
@@ -349,8 +482,7 @@
             </a:lvl1pPr>
           </a:lstStyle>
           <a:p>
-            <a:fld id="{CE5E9CC1-C706-0F49-92D6-E571CC5EEA8F}" type="slidenum">
-              <a:rPr lang="en-US"/>
+            <a:fld id="{05160769-A856-4042-9FE3-706669B0045B}" type="slidenum">
               <a:t>‹#›</a:t>
             </a:fld>
             <a:endParaRPr lang="en-US"/>
@@ -360,7 +492,7 @@
     </p:spTree>
     <p:extLst>
       <p:ext uri="{BB962C8B-B14F-4D97-AF65-F5344CB8AC3E}">
-        <p14:creationId xmlns:p14="http://schemas.microsoft.com/office/powerpoint/2010/main" val="1024086991"/>
+        <p14:creationId xmlns:p14="http://schemas.microsoft.com/office/powerpoint/2010/main" val="3311646734"/>
       </p:ext>
     </p:extLst>
   </p:cSld>
@@ -506,9 +638,16 @@
           <a:p>
             <a:r>
               <a:rPr lang="en-US" dirty="0"/>
-              <a:t>Synthetic mock training material. Visual style is synthetic and does not copy BP brand assets.</a:t>
-            </a:r>
-            <a:endParaRPr lang="en-US" dirty="0"/>
+              <a:t>Synthetic mock training material. Visual style is synthetic and does not copy </a:t>
+            </a:r>
+            <a:r>
+              <a:rPr lang="en-US"/>
+              <a:t>Contoso Energy</a:t>
+            </a:r>
+            <a:r>
+              <a:rPr lang="en-US" dirty="0"/>
+              <a:t> brand assets.</a:t>
+            </a:r>
           </a:p>
         </p:txBody>
       </p:sp>
@@ -596,7 +735,6 @@
               <a:rPr lang="en-US" dirty="0"/>
               <a:t>Synthetic mock training material. </a:t>
             </a:r>
-            <a:endParaRPr lang="en-US" dirty="0"/>
           </a:p>
         </p:txBody>
       </p:sp>
@@ -684,7 +822,6 @@
               <a:rPr lang="en-US" dirty="0"/>
               <a:t>Synthetic mock training material. </a:t>
             </a:r>
-            <a:endParaRPr lang="en-US" dirty="0"/>
           </a:p>
         </p:txBody>
       </p:sp>
@@ -772,7 +909,6 @@
               <a:rPr lang="en-US" dirty="0"/>
               <a:t>Synthetic mock training material. </a:t>
             </a:r>
-            <a:endParaRPr lang="en-US" dirty="0"/>
           </a:p>
         </p:txBody>
       </p:sp>
@@ -860,7 +996,6 @@
               <a:rPr lang="en-US" dirty="0"/>
               <a:t>Synthetic mock training material. </a:t>
             </a:r>
-            <a:endParaRPr lang="en-US" dirty="0"/>
           </a:p>
         </p:txBody>
       </p:sp>
@@ -933,6 +1068,11 @@
 <file path=ppt/slideMasters/slideMaster1.xml><?xml version="1.0" encoding="utf-8"?>
 <p:sldMaster xmlns:a="http://schemas.openxmlformats.org/drawingml/2006/main" xmlns:r="http://schemas.openxmlformats.org/officeDocument/2006/relationships" xmlns:p="http://schemas.openxmlformats.org/presentationml/2006/main">
   <p:cSld>
+    <p:bg>
+      <p:bgRef idx="1001">
+        <a:schemeClr val="bg1"/>
+      </p:bgRef>
+    </p:bg>
     <p:spTree>
       <p:nvGrpSpPr>
         <p:cNvPr id="1" name=""/>
@@ -1215,6 +1355,7 @@
         <a:solidFill>
           <a:srgbClr val="EAF7F1"/>
         </a:solidFill>
+        <a:effectLst/>
       </p:bgPr>
     </p:bg>
     <p:spTree>
@@ -1302,7 +1443,7 @@
           <a:bodyPr wrap="square" rtlCol="0" anchor="ctr"/>
           <a:lstStyle/>
           <a:p>
-            <a:pPr indent="0" marL="0">
+            <a:pPr marL="0" indent="0">
               <a:buNone/>
             </a:pPr>
             <a:r>
@@ -1328,7 +1469,7 @@
         </p:nvSpPr>
         <p:spPr>
           <a:xfrm>
-            <a:off x="758952" y="1828800"/>
+            <a:off x="758952" y="1886857"/>
             <a:ext cx="8961120" cy="320040"/>
           </a:xfrm>
           <a:prstGeom prst="rect">
@@ -1341,7 +1482,7 @@
           <a:bodyPr wrap="square" rtlCol="0" anchor="ctr"/>
           <a:lstStyle/>
           <a:p>
-            <a:pPr indent="0" marL="0">
+            <a:pPr marL="0" indent="0">
               <a:buNone/>
             </a:pPr>
             <a:r>
@@ -1409,7 +1550,7 @@
           <a:bodyPr wrap="square" lIns="127" tIns="127" rIns="127" bIns="127" rtlCol="0" anchor="ctr"/>
           <a:lstStyle/>
           <a:p>
-            <a:pPr indent="0" marL="0">
+            <a:pPr marL="0" indent="0">
               <a:buNone/>
             </a:pPr>
             <a:r>
@@ -1450,7 +1591,7 @@
           </a:bodyPr>
           <a:lstStyle/>
           <a:p>
-            <a:pPr indent="0" marL="0">
+            <a:pPr marL="0" indent="0">
               <a:buNone/>
             </a:pPr>
             <a:r>
@@ -1518,7 +1659,7 @@
           <a:bodyPr wrap="square" lIns="127" tIns="127" rIns="127" bIns="127" rtlCol="0" anchor="ctr"/>
           <a:lstStyle/>
           <a:p>
-            <a:pPr indent="0" marL="0">
+            <a:pPr marL="0" indent="0">
               <a:buNone/>
             </a:pPr>
             <a:r>
@@ -1559,7 +1700,7 @@
           </a:bodyPr>
           <a:lstStyle/>
           <a:p>
-            <a:pPr indent="0" marL="0">
+            <a:pPr marL="0" indent="0">
               <a:buNone/>
             </a:pPr>
             <a:r>
@@ -1627,7 +1768,7 @@
           <a:bodyPr wrap="square" lIns="127" tIns="127" rIns="127" bIns="127" rtlCol="0" anchor="ctr"/>
           <a:lstStyle/>
           <a:p>
-            <a:pPr indent="0" marL="0">
+            <a:pPr marL="0" indent="0">
               <a:buNone/>
             </a:pPr>
             <a:r>
@@ -1668,7 +1809,7 @@
           </a:bodyPr>
           <a:lstStyle/>
           <a:p>
-            <a:pPr indent="0" marL="0">
+            <a:pPr marL="0" indent="0">
               <a:buNone/>
             </a:pPr>
             <a:r>
@@ -1680,7 +1821,29 @@
                 <a:ea typeface="Aptos" pitchFamily="34" charset="-122"/>
                 <a:cs typeface="Aptos" pitchFamily="34" charset="-120"/>
               </a:rPr>
-              <a:t>No real BP data, logos, confidential content, or personal data.</a:t>
+              <a:t>No real </a:t>
+            </a:r>
+            <a:r>
+              <a:rPr lang="en-US" sz="1050">
+                <a:solidFill>
+                  <a:srgbClr val="1F2933"/>
+                </a:solidFill>
+                <a:latin typeface="Aptos" pitchFamily="34" charset="0"/>
+                <a:ea typeface="Aptos" pitchFamily="34" charset="-122"/>
+                <a:cs typeface="Aptos" pitchFamily="34" charset="-120"/>
+              </a:rPr>
+              <a:t>Contoso Energy</a:t>
+            </a:r>
+            <a:r>
+              <a:rPr lang="en-US" sz="1050" dirty="0">
+                <a:solidFill>
+                  <a:srgbClr val="1F2933"/>
+                </a:solidFill>
+                <a:latin typeface="Aptos" pitchFamily="34" charset="0"/>
+                <a:ea typeface="Aptos" pitchFamily="34" charset="-122"/>
+                <a:cs typeface="Aptos" pitchFamily="34" charset="-120"/>
+              </a:rPr>
+              <a:t> data, logos, confidential content, or personal data.</a:t>
             </a:r>
             <a:endParaRPr lang="en-US" sz="1050" dirty="0"/>
           </a:p>
@@ -1732,11 +1895,11 @@
           <a:bodyPr wrap="square" rtlCol="0" anchor="ctr"/>
           <a:lstStyle/>
           <a:p>
-            <a:pPr indent="0" marL="0">
+            <a:pPr marL="0" indent="0">
               <a:buNone/>
             </a:pPr>
             <a:r>
-              <a:rPr lang="en-US" sz="650" dirty="0">
+              <a:rPr lang="en-US" sz="650">
                 <a:solidFill>
                   <a:srgbClr val="FFFFFF"/>
                 </a:solidFill>
@@ -1744,7 +1907,40 @@
                 <a:ea typeface="Aptos" pitchFamily="34" charset="-122"/>
                 <a:cs typeface="Aptos" pitchFamily="34" charset="-120"/>
               </a:rPr>
-              <a:t>BP Malaysia Mock Training | Synthetic data only | No real BP confidential information</a:t>
+              <a:t>Contoso Energy </a:t>
+            </a:r>
+            <a:r>
+              <a:rPr lang="en-US" sz="650" dirty="0">
+                <a:solidFill>
+                  <a:srgbClr val="FFFFFF"/>
+                </a:solidFill>
+                <a:latin typeface="Aptos" pitchFamily="34" charset="0"/>
+                <a:ea typeface="Aptos" pitchFamily="34" charset="-122"/>
+                <a:cs typeface="Aptos" pitchFamily="34" charset="-120"/>
+              </a:rPr>
+              <a:t>Mock Training | Synthetic data only | No real </a:t>
+            </a:r>
+            <a:r>
+              <a:rPr lang="en-US" sz="650">
+                <a:solidFill>
+                  <a:srgbClr val="FFFFFF"/>
+                </a:solidFill>
+                <a:latin typeface="Aptos" pitchFamily="34" charset="0"/>
+                <a:ea typeface="Aptos" pitchFamily="34" charset="-122"/>
+                <a:cs typeface="Aptos" pitchFamily="34" charset="-120"/>
+              </a:rPr>
+              <a:t>Contoso Energy</a:t>
+            </a:r>
+            <a:r>
+              <a:rPr lang="en-US" sz="650" dirty="0">
+                <a:solidFill>
+                  <a:srgbClr val="FFFFFF"/>
+                </a:solidFill>
+                <a:latin typeface="Aptos" pitchFamily="34" charset="0"/>
+                <a:ea typeface="Aptos" pitchFamily="34" charset="-122"/>
+                <a:cs typeface="Aptos" pitchFamily="34" charset="-120"/>
+              </a:rPr>
+              <a:t> confidential information</a:t>
             </a:r>
             <a:endParaRPr lang="en-US" sz="650" dirty="0"/>
           </a:p>
@@ -1796,7 +1992,7 @@
           <a:bodyPr wrap="square" lIns="254" tIns="254" rIns="254" bIns="254" rtlCol="0" anchor="ctr"/>
           <a:lstStyle/>
           <a:p>
-            <a:pPr indent="0" marL="0">
+            <a:pPr marL="0" indent="0">
               <a:buNone/>
             </a:pPr>
             <a:r>
@@ -1835,7 +2031,7 @@
           <a:bodyPr wrap="square" lIns="254" tIns="254" rIns="254" bIns="254" rtlCol="0" anchor="ctr"/>
           <a:lstStyle/>
           <a:p>
-            <a:pPr indent="0" marL="0">
+            <a:pPr marL="0" indent="0">
               <a:buNone/>
             </a:pPr>
             <a:r>
@@ -1981,7 +2177,7 @@
           <a:bodyPr wrap="square" lIns="127" tIns="127" rIns="127" bIns="127" rtlCol="0" anchor="ctr"/>
           <a:lstStyle/>
           <a:p>
-            <a:pPr indent="0" marL="0">
+            <a:pPr marL="0" indent="0">
               <a:buNone/>
             </a:pPr>
             <a:r>
@@ -2022,7 +2218,7 @@
           </a:bodyPr>
           <a:lstStyle/>
           <a:p>
-            <a:pPr indent="0" marL="0">
+            <a:pPr marL="0" indent="0">
               <a:buNone/>
             </a:pPr>
             <a:r>
@@ -2090,7 +2286,7 @@
           <a:bodyPr wrap="square" lIns="127" tIns="127" rIns="127" bIns="127" rtlCol="0" anchor="ctr"/>
           <a:lstStyle/>
           <a:p>
-            <a:pPr indent="0" marL="0">
+            <a:pPr marL="0" indent="0">
               <a:buNone/>
             </a:pPr>
             <a:r>
@@ -2131,7 +2327,7 @@
           </a:bodyPr>
           <a:lstStyle/>
           <a:p>
-            <a:pPr indent="0" marL="0">
+            <a:pPr marL="0" indent="0">
               <a:buNone/>
             </a:pPr>
             <a:r>
@@ -2199,7 +2395,7 @@
           <a:bodyPr wrap="square" lIns="127" tIns="127" rIns="127" bIns="127" rtlCol="0" anchor="ctr"/>
           <a:lstStyle/>
           <a:p>
-            <a:pPr indent="0" marL="0">
+            <a:pPr marL="0" indent="0">
               <a:buNone/>
             </a:pPr>
             <a:r>
@@ -2240,7 +2436,7 @@
           </a:bodyPr>
           <a:lstStyle/>
           <a:p>
-            <a:pPr indent="0" marL="0">
+            <a:pPr marL="0" indent="0">
               <a:buNone/>
             </a:pPr>
             <a:r>
@@ -2308,7 +2504,7 @@
           <a:bodyPr wrap="square" lIns="127" tIns="127" rIns="127" bIns="127" rtlCol="0" anchor="ctr"/>
           <a:lstStyle/>
           <a:p>
-            <a:pPr indent="0" marL="0">
+            <a:pPr marL="0" indent="0">
               <a:buNone/>
             </a:pPr>
             <a:r>
@@ -2349,7 +2545,7 @@
           </a:bodyPr>
           <a:lstStyle/>
           <a:p>
-            <a:pPr indent="0" marL="0">
+            <a:pPr marL="0" indent="0">
               <a:buNone/>
             </a:pPr>
             <a:r>
@@ -2413,11 +2609,11 @@
           <a:bodyPr wrap="square" rtlCol="0" anchor="ctr"/>
           <a:lstStyle/>
           <a:p>
-            <a:pPr indent="0" marL="0">
+            <a:pPr marL="0" indent="0">
               <a:buNone/>
             </a:pPr>
             <a:r>
-              <a:rPr lang="en-US" sz="650" dirty="0">
+              <a:rPr lang="en-US" sz="650">
                 <a:solidFill>
                   <a:srgbClr val="FFFFFF"/>
                 </a:solidFill>
@@ -2425,7 +2621,40 @@
                 <a:ea typeface="Aptos" pitchFamily="34" charset="-122"/>
                 <a:cs typeface="Aptos" pitchFamily="34" charset="-120"/>
               </a:rPr>
-              <a:t>BP Malaysia Mock Training | Synthetic data only | No real BP confidential information</a:t>
+              <a:t>Contoso Energy </a:t>
+            </a:r>
+            <a:r>
+              <a:rPr lang="en-US" sz="650" dirty="0">
+                <a:solidFill>
+                  <a:srgbClr val="FFFFFF"/>
+                </a:solidFill>
+                <a:latin typeface="Aptos" pitchFamily="34" charset="0"/>
+                <a:ea typeface="Aptos" pitchFamily="34" charset="-122"/>
+                <a:cs typeface="Aptos" pitchFamily="34" charset="-120"/>
+              </a:rPr>
+              <a:t>Mock Training | Synthetic data only | No real </a:t>
+            </a:r>
+            <a:r>
+              <a:rPr lang="en-US" sz="650">
+                <a:solidFill>
+                  <a:srgbClr val="FFFFFF"/>
+                </a:solidFill>
+                <a:latin typeface="Aptos" pitchFamily="34" charset="0"/>
+                <a:ea typeface="Aptos" pitchFamily="34" charset="-122"/>
+                <a:cs typeface="Aptos" pitchFamily="34" charset="-120"/>
+              </a:rPr>
+              <a:t>Contoso Energy</a:t>
+            </a:r>
+            <a:r>
+              <a:rPr lang="en-US" sz="650" dirty="0">
+                <a:solidFill>
+                  <a:srgbClr val="FFFFFF"/>
+                </a:solidFill>
+                <a:latin typeface="Aptos" pitchFamily="34" charset="0"/>
+                <a:ea typeface="Aptos" pitchFamily="34" charset="-122"/>
+                <a:cs typeface="Aptos" pitchFamily="34" charset="-120"/>
+              </a:rPr>
+              <a:t> confidential information</a:t>
             </a:r>
             <a:endParaRPr lang="en-US" sz="650" dirty="0"/>
           </a:p>
@@ -2477,7 +2706,7 @@
           <a:bodyPr wrap="square" lIns="254" tIns="254" rIns="254" bIns="254" rtlCol="0" anchor="ctr"/>
           <a:lstStyle/>
           <a:p>
-            <a:pPr indent="0" marL="0">
+            <a:pPr marL="0" indent="0">
               <a:buNone/>
             </a:pPr>
             <a:r>
@@ -2516,7 +2745,7 @@
           <a:bodyPr wrap="square" lIns="254" tIns="254" rIns="254" bIns="254" rtlCol="0" anchor="ctr"/>
           <a:lstStyle/>
           <a:p>
-            <a:pPr indent="0" marL="0">
+            <a:pPr marL="0" indent="0">
               <a:buNone/>
             </a:pPr>
             <a:r>
@@ -2557,9 +2786,27 @@
             <a:tbl>
               <a:tblPr/>
               <a:tblGrid>
-                <a:gridCol w="3627120"/>
-                <a:gridCol w="3627120"/>
-                <a:gridCol w="3627120"/>
+                <a:gridCol w="3627120">
+                  <a:extLst>
+                    <a:ext uri="{9D8B030D-6E8A-4147-A177-3AD203B41FA5}">
+                      <a16:colId xmlns:a16="http://schemas.microsoft.com/office/drawing/2014/main" val="20000"/>
+                    </a:ext>
+                  </a:extLst>
+                </a:gridCol>
+                <a:gridCol w="3627120">
+                  <a:extLst>
+                    <a:ext uri="{9D8B030D-6E8A-4147-A177-3AD203B41FA5}">
+                      <a16:colId xmlns:a16="http://schemas.microsoft.com/office/drawing/2014/main" val="20001"/>
+                    </a:ext>
+                  </a:extLst>
+                </a:gridCol>
+                <a:gridCol w="3627120">
+                  <a:extLst>
+                    <a:ext uri="{9D8B030D-6E8A-4147-A177-3AD203B41FA5}">
+                      <a16:colId xmlns:a16="http://schemas.microsoft.com/office/drawing/2014/main" val="20002"/>
+                    </a:ext>
+                  </a:extLst>
+                </a:gridCol>
               </a:tblGrid>
               <a:tr h="585216">
                 <a:tc>
@@ -2567,7 +2814,7 @@
                     <a:bodyPr/>
                     <a:lstStyle/>
                     <a:p>
-                      <a:pPr indent="0" marL="0">
+                      <a:pPr marL="0" indent="0">
                         <a:buNone/>
                       </a:pPr>
                       <a:r>
@@ -2635,7 +2882,7 @@
                     <a:bodyPr/>
                     <a:lstStyle/>
                     <a:p>
-                      <a:pPr indent="0" marL="0">
+                      <a:pPr marL="0" indent="0">
                         <a:buNone/>
                       </a:pPr>
                       <a:r>
@@ -2703,7 +2950,7 @@
                     <a:bodyPr/>
                     <a:lstStyle/>
                     <a:p>
-                      <a:pPr indent="0" marL="0">
+                      <a:pPr marL="0" indent="0">
                         <a:buNone/>
                       </a:pPr>
                       <a:r>
@@ -2766,6 +3013,11 @@
                     </a:solidFill>
                   </a:tcPr>
                 </a:tc>
+                <a:extLst>
+                  <a:ext uri="{0D108BD9-81ED-4DB2-BD59-A6C34878D82A}">
+                    <a16:rowId xmlns:a16="http://schemas.microsoft.com/office/drawing/2014/main" val="10000"/>
+                  </a:ext>
+                </a:extLst>
               </a:tr>
               <a:tr h="585216">
                 <a:tc>
@@ -2773,7 +3025,7 @@
                     <a:bodyPr/>
                     <a:lstStyle/>
                     <a:p>
-                      <a:pPr indent="0" marL="0">
+                      <a:pPr marL="0" indent="0">
                         <a:buNone/>
                       </a:pPr>
                       <a:r>
@@ -2841,7 +3093,7 @@
                     <a:bodyPr/>
                     <a:lstStyle/>
                     <a:p>
-                      <a:pPr indent="0" marL="0">
+                      <a:pPr marL="0" indent="0">
                         <a:buNone/>
                       </a:pPr>
                       <a:r>
@@ -2909,7 +3161,7 @@
                     <a:bodyPr/>
                     <a:lstStyle/>
                     <a:p>
-                      <a:pPr indent="0" marL="0">
+                      <a:pPr marL="0" indent="0">
                         <a:buNone/>
                       </a:pPr>
                       <a:r>
@@ -2972,6 +3224,11 @@
                     </a:solidFill>
                   </a:tcPr>
                 </a:tc>
+                <a:extLst>
+                  <a:ext uri="{0D108BD9-81ED-4DB2-BD59-A6C34878D82A}">
+                    <a16:rowId xmlns:a16="http://schemas.microsoft.com/office/drawing/2014/main" val="10001"/>
+                  </a:ext>
+                </a:extLst>
               </a:tr>
               <a:tr h="585216">
                 <a:tc>
@@ -2979,7 +3236,7 @@
                     <a:bodyPr/>
                     <a:lstStyle/>
                     <a:p>
-                      <a:pPr indent="0" marL="0">
+                      <a:pPr marL="0" indent="0">
                         <a:buNone/>
                       </a:pPr>
                       <a:r>
@@ -3047,7 +3304,7 @@
                     <a:bodyPr/>
                     <a:lstStyle/>
                     <a:p>
-                      <a:pPr indent="0" marL="0">
+                      <a:pPr marL="0" indent="0">
                         <a:buNone/>
                       </a:pPr>
                       <a:r>
@@ -3115,7 +3372,7 @@
                     <a:bodyPr/>
                     <a:lstStyle/>
                     <a:p>
-                      <a:pPr indent="0" marL="0">
+                      <a:pPr marL="0" indent="0">
                         <a:buNone/>
                       </a:pPr>
                       <a:r>
@@ -3178,6 +3435,11 @@
                     </a:solidFill>
                   </a:tcPr>
                 </a:tc>
+                <a:extLst>
+                  <a:ext uri="{0D108BD9-81ED-4DB2-BD59-A6C34878D82A}">
+                    <a16:rowId xmlns:a16="http://schemas.microsoft.com/office/drawing/2014/main" val="10002"/>
+                  </a:ext>
+                </a:extLst>
               </a:tr>
               <a:tr h="585216">
                 <a:tc>
@@ -3185,7 +3447,7 @@
                     <a:bodyPr/>
                     <a:lstStyle/>
                     <a:p>
-                      <a:pPr indent="0" marL="0">
+                      <a:pPr marL="0" indent="0">
                         <a:buNone/>
                       </a:pPr>
                       <a:r>
@@ -3253,7 +3515,7 @@
                     <a:bodyPr/>
                     <a:lstStyle/>
                     <a:p>
-                      <a:pPr indent="0" marL="0">
+                      <a:pPr marL="0" indent="0">
                         <a:buNone/>
                       </a:pPr>
                       <a:r>
@@ -3321,7 +3583,7 @@
                     <a:bodyPr/>
                     <a:lstStyle/>
                     <a:p>
-                      <a:pPr indent="0" marL="0">
+                      <a:pPr marL="0" indent="0">
                         <a:buNone/>
                       </a:pPr>
                       <a:r>
@@ -3384,6 +3646,11 @@
                     </a:solidFill>
                   </a:tcPr>
                 </a:tc>
+                <a:extLst>
+                  <a:ext uri="{0D108BD9-81ED-4DB2-BD59-A6C34878D82A}">
+                    <a16:rowId xmlns:a16="http://schemas.microsoft.com/office/drawing/2014/main" val="10003"/>
+                  </a:ext>
+                </a:extLst>
               </a:tr>
               <a:tr h="585216">
                 <a:tc>
@@ -3391,7 +3658,7 @@
                     <a:bodyPr/>
                     <a:lstStyle/>
                     <a:p>
-                      <a:pPr indent="0" marL="0">
+                      <a:pPr marL="0" indent="0">
                         <a:buNone/>
                       </a:pPr>
                       <a:r>
@@ -3459,7 +3726,7 @@
                     <a:bodyPr/>
                     <a:lstStyle/>
                     <a:p>
-                      <a:pPr indent="0" marL="0">
+                      <a:pPr marL="0" indent="0">
                         <a:buNone/>
                       </a:pPr>
                       <a:r>
@@ -3527,7 +3794,7 @@
                     <a:bodyPr/>
                     <a:lstStyle/>
                     <a:p>
-                      <a:pPr indent="0" marL="0">
+                      <a:pPr marL="0" indent="0">
                         <a:buNone/>
                       </a:pPr>
                       <a:r>
@@ -3590,6 +3857,11 @@
                     </a:solidFill>
                   </a:tcPr>
                 </a:tc>
+                <a:extLst>
+                  <a:ext uri="{0D108BD9-81ED-4DB2-BD59-A6C34878D82A}">
+                    <a16:rowId xmlns:a16="http://schemas.microsoft.com/office/drawing/2014/main" val="10004"/>
+                  </a:ext>
+                </a:extLst>
               </a:tr>
             </a:tbl>
           </a:graphicData>
@@ -3641,11 +3913,11 @@
           <a:bodyPr wrap="square" rtlCol="0" anchor="ctr"/>
           <a:lstStyle/>
           <a:p>
-            <a:pPr indent="0" marL="0">
+            <a:pPr marL="0" indent="0">
               <a:buNone/>
             </a:pPr>
             <a:r>
-              <a:rPr lang="en-US" sz="650" dirty="0">
+              <a:rPr lang="en-US" sz="650">
                 <a:solidFill>
                   <a:srgbClr val="FFFFFF"/>
                 </a:solidFill>
@@ -3653,7 +3925,40 @@
                 <a:ea typeface="Aptos" pitchFamily="34" charset="-122"/>
                 <a:cs typeface="Aptos" pitchFamily="34" charset="-120"/>
               </a:rPr>
-              <a:t>BP Malaysia Mock Training | Synthetic data only | No real BP confidential information</a:t>
+              <a:t>Contoso Energy </a:t>
+            </a:r>
+            <a:r>
+              <a:rPr lang="en-US" sz="650" dirty="0">
+                <a:solidFill>
+                  <a:srgbClr val="FFFFFF"/>
+                </a:solidFill>
+                <a:latin typeface="Aptos" pitchFamily="34" charset="0"/>
+                <a:ea typeface="Aptos" pitchFamily="34" charset="-122"/>
+                <a:cs typeface="Aptos" pitchFamily="34" charset="-120"/>
+              </a:rPr>
+              <a:t>Mock Training | Synthetic data only | No real </a:t>
+            </a:r>
+            <a:r>
+              <a:rPr lang="en-US" sz="650">
+                <a:solidFill>
+                  <a:srgbClr val="FFFFFF"/>
+                </a:solidFill>
+                <a:latin typeface="Aptos" pitchFamily="34" charset="0"/>
+                <a:ea typeface="Aptos" pitchFamily="34" charset="-122"/>
+                <a:cs typeface="Aptos" pitchFamily="34" charset="-120"/>
+              </a:rPr>
+              <a:t>Contoso Energy</a:t>
+            </a:r>
+            <a:r>
+              <a:rPr lang="en-US" sz="650" dirty="0">
+                <a:solidFill>
+                  <a:srgbClr val="FFFFFF"/>
+                </a:solidFill>
+                <a:latin typeface="Aptos" pitchFamily="34" charset="0"/>
+                <a:ea typeface="Aptos" pitchFamily="34" charset="-122"/>
+                <a:cs typeface="Aptos" pitchFamily="34" charset="-120"/>
+              </a:rPr>
+              <a:t> confidential information</a:t>
             </a:r>
             <a:endParaRPr lang="en-US" sz="650" dirty="0"/>
           </a:p>
@@ -3705,7 +4010,7 @@
           <a:bodyPr wrap="square" lIns="254" tIns="254" rIns="254" bIns="254" rtlCol="0" anchor="ctr"/>
           <a:lstStyle/>
           <a:p>
-            <a:pPr indent="0" marL="0">
+            <a:pPr marL="0" indent="0">
               <a:buNone/>
             </a:pPr>
             <a:r>
@@ -3744,7 +4049,7 @@
           <a:bodyPr wrap="square" lIns="254" tIns="254" rIns="254" bIns="254" rtlCol="0" anchor="ctr"/>
           <a:lstStyle/>
           <a:p>
-            <a:pPr indent="0" marL="0">
+            <a:pPr marL="0" indent="0">
               <a:buNone/>
             </a:pPr>
             <a:r>
@@ -3812,7 +4117,7 @@
           <a:bodyPr wrap="square" lIns="127" tIns="127" rIns="127" bIns="127" rtlCol="0" anchor="ctr"/>
           <a:lstStyle/>
           <a:p>
-            <a:pPr indent="0" marL="0">
+            <a:pPr marL="0" indent="0">
               <a:buNone/>
             </a:pPr>
             <a:r>
@@ -3853,7 +4158,7 @@
           </a:bodyPr>
           <a:lstStyle/>
           <a:p>
-            <a:pPr indent="0" marL="0">
+            <a:pPr marL="0" indent="0">
               <a:buNone/>
             </a:pPr>
             <a:r>
@@ -3921,7 +4226,7 @@
           <a:bodyPr wrap="square" lIns="127" tIns="127" rIns="127" bIns="127" rtlCol="0" anchor="ctr"/>
           <a:lstStyle/>
           <a:p>
-            <a:pPr indent="0" marL="0">
+            <a:pPr marL="0" indent="0">
               <a:buNone/>
             </a:pPr>
             <a:r>
@@ -3962,7 +4267,7 @@
           </a:bodyPr>
           <a:lstStyle/>
           <a:p>
-            <a:pPr indent="0" marL="0">
+            <a:pPr marL="0" indent="0">
               <a:buNone/>
             </a:pPr>
             <a:r>
@@ -4030,7 +4335,7 @@
           <a:bodyPr wrap="square" lIns="127" tIns="127" rIns="127" bIns="127" rtlCol="0" anchor="ctr"/>
           <a:lstStyle/>
           <a:p>
-            <a:pPr indent="0" marL="0">
+            <a:pPr marL="0" indent="0">
               <a:buNone/>
             </a:pPr>
             <a:r>
@@ -4071,7 +4376,7 @@
           </a:bodyPr>
           <a:lstStyle/>
           <a:p>
-            <a:pPr indent="0" marL="0">
+            <a:pPr marL="0" indent="0">
               <a:buNone/>
             </a:pPr>
             <a:r>
@@ -4177,11 +4482,11 @@
           <a:bodyPr wrap="square" rtlCol="0" anchor="ctr"/>
           <a:lstStyle/>
           <a:p>
-            <a:pPr indent="0" marL="0">
+            <a:pPr marL="0" indent="0">
               <a:buNone/>
             </a:pPr>
             <a:r>
-              <a:rPr lang="en-US" sz="650" dirty="0">
+              <a:rPr lang="en-US" sz="650">
                 <a:solidFill>
                   <a:srgbClr val="FFFFFF"/>
                 </a:solidFill>
@@ -4189,7 +4494,40 @@
                 <a:ea typeface="Aptos" pitchFamily="34" charset="-122"/>
                 <a:cs typeface="Aptos" pitchFamily="34" charset="-120"/>
               </a:rPr>
-              <a:t>BP Malaysia Mock Training | Synthetic data only | No real BP confidential information</a:t>
+              <a:t>Contoso Energy </a:t>
+            </a:r>
+            <a:r>
+              <a:rPr lang="en-US" sz="650" dirty="0">
+                <a:solidFill>
+                  <a:srgbClr val="FFFFFF"/>
+                </a:solidFill>
+                <a:latin typeface="Aptos" pitchFamily="34" charset="0"/>
+                <a:ea typeface="Aptos" pitchFamily="34" charset="-122"/>
+                <a:cs typeface="Aptos" pitchFamily="34" charset="-120"/>
+              </a:rPr>
+              <a:t>Mock Training | Synthetic data only | No real </a:t>
+            </a:r>
+            <a:r>
+              <a:rPr lang="en-US" sz="650">
+                <a:solidFill>
+                  <a:srgbClr val="FFFFFF"/>
+                </a:solidFill>
+                <a:latin typeface="Aptos" pitchFamily="34" charset="0"/>
+                <a:ea typeface="Aptos" pitchFamily="34" charset="-122"/>
+                <a:cs typeface="Aptos" pitchFamily="34" charset="-120"/>
+              </a:rPr>
+              <a:t>Contoso Energy</a:t>
+            </a:r>
+            <a:r>
+              <a:rPr lang="en-US" sz="650" dirty="0">
+                <a:solidFill>
+                  <a:srgbClr val="FFFFFF"/>
+                </a:solidFill>
+                <a:latin typeface="Aptos" pitchFamily="34" charset="0"/>
+                <a:ea typeface="Aptos" pitchFamily="34" charset="-122"/>
+                <a:cs typeface="Aptos" pitchFamily="34" charset="-120"/>
+              </a:rPr>
+              <a:t> confidential information</a:t>
             </a:r>
             <a:endParaRPr lang="en-US" sz="650" dirty="0"/>
           </a:p>
@@ -4241,7 +4579,7 @@
           <a:bodyPr wrap="square" lIns="254" tIns="254" rIns="254" bIns="254" rtlCol="0" anchor="ctr"/>
           <a:lstStyle/>
           <a:p>
-            <a:pPr indent="0" marL="0">
+            <a:pPr marL="0" indent="0">
               <a:buNone/>
             </a:pPr>
             <a:r>
@@ -4280,7 +4618,7 @@
           <a:bodyPr wrap="square" lIns="254" tIns="254" rIns="254" bIns="254" rtlCol="0" anchor="ctr"/>
           <a:lstStyle/>
           <a:p>
-            <a:pPr indent="0" marL="0">
+            <a:pPr marL="0" indent="0">
               <a:buNone/>
             </a:pPr>
             <a:r>
@@ -4440,11 +4778,11 @@
           <a:bodyPr wrap="square" rtlCol="0" anchor="ctr"/>
           <a:lstStyle/>
           <a:p>
-            <a:pPr indent="0" marL="0">
+            <a:pPr marL="0" indent="0">
               <a:buNone/>
             </a:pPr>
             <a:r>
-              <a:rPr lang="en-US" sz="650" dirty="0">
+              <a:rPr lang="en-US" sz="650">
                 <a:solidFill>
                   <a:srgbClr val="FFFFFF"/>
                 </a:solidFill>
@@ -4452,7 +4790,40 @@
                 <a:ea typeface="Aptos" pitchFamily="34" charset="-122"/>
                 <a:cs typeface="Aptos" pitchFamily="34" charset="-120"/>
               </a:rPr>
-              <a:t>BP Malaysia Mock Training | Synthetic data only | No real BP confidential information</a:t>
+              <a:t>Contoso Energy </a:t>
+            </a:r>
+            <a:r>
+              <a:rPr lang="en-US" sz="650" dirty="0">
+                <a:solidFill>
+                  <a:srgbClr val="FFFFFF"/>
+                </a:solidFill>
+                <a:latin typeface="Aptos" pitchFamily="34" charset="0"/>
+                <a:ea typeface="Aptos" pitchFamily="34" charset="-122"/>
+                <a:cs typeface="Aptos" pitchFamily="34" charset="-120"/>
+              </a:rPr>
+              <a:t>Mock Training | Synthetic data only | No real </a:t>
+            </a:r>
+            <a:r>
+              <a:rPr lang="en-US" sz="650">
+                <a:solidFill>
+                  <a:srgbClr val="FFFFFF"/>
+                </a:solidFill>
+                <a:latin typeface="Aptos" pitchFamily="34" charset="0"/>
+                <a:ea typeface="Aptos" pitchFamily="34" charset="-122"/>
+                <a:cs typeface="Aptos" pitchFamily="34" charset="-120"/>
+              </a:rPr>
+              <a:t>Contoso Energy</a:t>
+            </a:r>
+            <a:r>
+              <a:rPr lang="en-US" sz="650" dirty="0">
+                <a:solidFill>
+                  <a:srgbClr val="FFFFFF"/>
+                </a:solidFill>
+                <a:latin typeface="Aptos" pitchFamily="34" charset="0"/>
+                <a:ea typeface="Aptos" pitchFamily="34" charset="-122"/>
+                <a:cs typeface="Aptos" pitchFamily="34" charset="-120"/>
+              </a:rPr>
+              <a:t> confidential information</a:t>
             </a:r>
             <a:endParaRPr lang="en-US" sz="650" dirty="0"/>
           </a:p>
@@ -4759,4 +5130,299 @@
     </a:ext>
   </a:extLst>
 </a:theme>
+</file>
+
+<file path=ppt/theme/theme2.xml><?xml version="1.0" encoding="utf-8"?>
+<a:theme xmlns:a="http://schemas.openxmlformats.org/drawingml/2006/main" name="Office Theme">
+  <a:themeElements>
+    <a:clrScheme name="Office">
+      <a:dk1>
+        <a:sysClr val="windowText" lastClr="000000"/>
+      </a:dk1>
+      <a:lt1>
+        <a:sysClr val="window" lastClr="FFFFFF"/>
+      </a:lt1>
+      <a:dk2>
+        <a:srgbClr val="44546A"/>
+      </a:dk2>
+      <a:lt2>
+        <a:srgbClr val="E7E6E6"/>
+      </a:lt2>
+      <a:accent1>
+        <a:srgbClr val="4472C4"/>
+      </a:accent1>
+      <a:accent2>
+        <a:srgbClr val="ED7D31"/>
+      </a:accent2>
+      <a:accent3>
+        <a:srgbClr val="A5A5A5"/>
+      </a:accent3>
+      <a:accent4>
+        <a:srgbClr val="FFC000"/>
+      </a:accent4>
+      <a:accent5>
+        <a:srgbClr val="5B9BD5"/>
+      </a:accent5>
+      <a:accent6>
+        <a:srgbClr val="70AD47"/>
+      </a:accent6>
+      <a:hlink>
+        <a:srgbClr val="0563C1"/>
+      </a:hlink>
+      <a:folHlink>
+        <a:srgbClr val="954F72"/>
+      </a:folHlink>
+    </a:clrScheme>
+    <a:fontScheme name="Office">
+      <a:majorFont>
+        <a:latin typeface="Calibri Light" panose="020F0302020204030204"/>
+        <a:ea typeface=""/>
+        <a:cs typeface=""/>
+        <a:font script="Jpan" typeface="游ゴシック Light"/>
+        <a:font script="Hang" typeface="맑은 고딕"/>
+        <a:font script="Hans" typeface="等线 Light"/>
+        <a:font script="Hant" typeface="新細明體"/>
+        <a:font script="Arab" typeface="Times New Roman"/>
+        <a:font script="Hebr" typeface="Times New Roman"/>
+        <a:font script="Thai" typeface="Angsana New"/>
+        <a:font script="Ethi" typeface="Nyala"/>
+        <a:font script="Beng" typeface="Vrinda"/>
+        <a:font script="Gujr" typeface="Shruti"/>
+        <a:font script="Khmr" typeface="MoolBoran"/>
+        <a:font script="Knda" typeface="Tunga"/>
+        <a:font script="Guru" typeface="Raavi"/>
+        <a:font script="Cans" typeface="Euphemia"/>
+        <a:font script="Cher" typeface="Plantagenet Cherokee"/>
+        <a:font script="Yiii" typeface="Microsoft Yi Baiti"/>
+        <a:font script="Tibt" typeface="Microsoft Himalaya"/>
+        <a:font script="Thaa" typeface="MV Boli"/>
+        <a:font script="Deva" typeface="Mangal"/>
+        <a:font script="Telu" typeface="Gautami"/>
+        <a:font script="Taml" typeface="Latha"/>
+        <a:font script="Syrc" typeface="Estrangelo Edessa"/>
+        <a:font script="Orya" typeface="Kalinga"/>
+        <a:font script="Mlym" typeface="Kartika"/>
+        <a:font script="Laoo" typeface="DokChampa"/>
+        <a:font script="Sinh" typeface="Iskoola Pota"/>
+        <a:font script="Mong" typeface="Mongolian Baiti"/>
+        <a:font script="Viet" typeface="Times New Roman"/>
+        <a:font script="Uigh" typeface="Microsoft Uighur"/>
+        <a:font script="Geor" typeface="Sylfaen"/>
+        <a:font script="Armn" typeface="Arial"/>
+        <a:font script="Bugi" typeface="Leelawadee UI"/>
+        <a:font script="Bopo" typeface="Microsoft JhengHei"/>
+        <a:font script="Java" typeface="Javanese Text"/>
+        <a:font script="Lisu" typeface="Segoe UI"/>
+        <a:font script="Mymr" typeface="Myanmar Text"/>
+        <a:font script="Nkoo" typeface="Ebrima"/>
+        <a:font script="Olck" typeface="Nirmala UI"/>
+        <a:font script="Osma" typeface="Ebrima"/>
+        <a:font script="Phag" typeface="Phagspa"/>
+        <a:font script="Syrn" typeface="Estrangelo Edessa"/>
+        <a:font script="Syrj" typeface="Estrangelo Edessa"/>
+        <a:font script="Syre" typeface="Estrangelo Edessa"/>
+        <a:font script="Sora" typeface="Nirmala UI"/>
+        <a:font script="Tale" typeface="Microsoft Tai Le"/>
+        <a:font script="Talu" typeface="Microsoft New Tai Lue"/>
+        <a:font script="Tfng" typeface="Ebrima"/>
+      </a:majorFont>
+      <a:minorFont>
+        <a:latin typeface="Calibri" panose="020F0502020204030204"/>
+        <a:ea typeface=""/>
+        <a:cs typeface=""/>
+        <a:font script="Jpan" typeface="游ゴシック"/>
+        <a:font script="Hang" typeface="맑은 고딕"/>
+        <a:font script="Hans" typeface="等线"/>
+        <a:font script="Hant" typeface="新細明體"/>
+        <a:font script="Arab" typeface="Arial"/>
+        <a:font script="Hebr" typeface="Arial"/>
+        <a:font script="Thai" typeface="Cordia New"/>
+        <a:font script="Ethi" typeface="Nyala"/>
+        <a:font script="Beng" typeface="Vrinda"/>
+        <a:font script="Gujr" typeface="Shruti"/>
+        <a:font script="Khmr" typeface="DaunPenh"/>
+        <a:font script="Knda" typeface="Tunga"/>
+        <a:font script="Guru" typeface="Raavi"/>
+        <a:font script="Cans" typeface="Euphemia"/>
+        <a:font script="Cher" typeface="Plantagenet Cherokee"/>
+        <a:font script="Yiii" typeface="Microsoft Yi Baiti"/>
+        <a:font script="Tibt" typeface="Microsoft Himalaya"/>
+        <a:font script="Thaa" typeface="MV Boli"/>
+        <a:font script="Deva" typeface="Mangal"/>
+        <a:font script="Telu" typeface="Gautami"/>
+        <a:font script="Taml" typeface="Latha"/>
+        <a:font script="Syrc" typeface="Estrangelo Edessa"/>
+        <a:font script="Orya" typeface="Kalinga"/>
+        <a:font script="Mlym" typeface="Kartika"/>
+        <a:font script="Laoo" typeface="DokChampa"/>
+        <a:font script="Sinh" typeface="Iskoola Pota"/>
+        <a:font script="Mong" typeface="Mongolian Baiti"/>
+        <a:font script="Viet" typeface="Arial"/>
+        <a:font script="Uigh" typeface="Microsoft Uighur"/>
+        <a:font script="Geor" typeface="Sylfaen"/>
+        <a:font script="Armn" typeface="Arial"/>
+        <a:font script="Bugi" typeface="Leelawadee UI"/>
+        <a:font script="Bopo" typeface="Microsoft JhengHei"/>
+        <a:font script="Java" typeface="Javanese Text"/>
+        <a:font script="Lisu" typeface="Segoe UI"/>
+        <a:font script="Mymr" typeface="Myanmar Text"/>
+        <a:font script="Nkoo" typeface="Ebrima"/>
+        <a:font script="Olck" typeface="Nirmala UI"/>
+        <a:font script="Osma" typeface="Ebrima"/>
+        <a:font script="Phag" typeface="Phagspa"/>
+        <a:font script="Syrn" typeface="Estrangelo Edessa"/>
+        <a:font script="Syrj" typeface="Estrangelo Edessa"/>
+        <a:font script="Syre" typeface="Estrangelo Edessa"/>
+        <a:font script="Sora" typeface="Nirmala UI"/>
+        <a:font script="Tale" typeface="Microsoft Tai Le"/>
+        <a:font script="Talu" typeface="Microsoft New Tai Lue"/>
+        <a:font script="Tfng" typeface="Ebrima"/>
+      </a:minorFont>
+    </a:fontScheme>
+    <a:fmtScheme name="Office">
+      <a:fillStyleLst>
+        <a:solidFill>
+          <a:schemeClr val="phClr"/>
+        </a:solidFill>
+        <a:gradFill rotWithShape="1">
+          <a:gsLst>
+            <a:gs pos="0">
+              <a:schemeClr val="phClr">
+                <a:lumMod val="110000"/>
+                <a:satMod val="105000"/>
+                <a:tint val="67000"/>
+              </a:schemeClr>
+            </a:gs>
+            <a:gs pos="50000">
+              <a:schemeClr val="phClr">
+                <a:lumMod val="105000"/>
+                <a:satMod val="103000"/>
+                <a:tint val="73000"/>
+              </a:schemeClr>
+            </a:gs>
+            <a:gs pos="100000">
+              <a:schemeClr val="phClr">
+                <a:lumMod val="105000"/>
+                <a:satMod val="109000"/>
+                <a:tint val="81000"/>
+              </a:schemeClr>
+            </a:gs>
+          </a:gsLst>
+          <a:lin ang="5400000" scaled="0"/>
+        </a:gradFill>
+        <a:gradFill rotWithShape="1">
+          <a:gsLst>
+            <a:gs pos="0">
+              <a:schemeClr val="phClr">
+                <a:satMod val="103000"/>
+                <a:lumMod val="102000"/>
+                <a:tint val="94000"/>
+              </a:schemeClr>
+            </a:gs>
+            <a:gs pos="50000">
+              <a:schemeClr val="phClr">
+                <a:satMod val="110000"/>
+                <a:lumMod val="100000"/>
+                <a:shade val="100000"/>
+              </a:schemeClr>
+            </a:gs>
+            <a:gs pos="100000">
+              <a:schemeClr val="phClr">
+                <a:lumMod val="99000"/>
+                <a:satMod val="120000"/>
+                <a:shade val="78000"/>
+              </a:schemeClr>
+            </a:gs>
+          </a:gsLst>
+          <a:lin ang="5400000" scaled="0"/>
+        </a:gradFill>
+      </a:fillStyleLst>
+      <a:lnStyleLst>
+        <a:ln w="6350" cap="flat" cmpd="sng" algn="ctr">
+          <a:solidFill>
+            <a:schemeClr val="phClr"/>
+          </a:solidFill>
+          <a:prstDash val="solid"/>
+          <a:miter lim="800000"/>
+        </a:ln>
+        <a:ln w="12700" cap="flat" cmpd="sng" algn="ctr">
+          <a:solidFill>
+            <a:schemeClr val="phClr"/>
+          </a:solidFill>
+          <a:prstDash val="solid"/>
+          <a:miter lim="800000"/>
+        </a:ln>
+        <a:ln w="19050" cap="flat" cmpd="sng" algn="ctr">
+          <a:solidFill>
+            <a:schemeClr val="phClr"/>
+          </a:solidFill>
+          <a:prstDash val="solid"/>
+          <a:miter lim="800000"/>
+        </a:ln>
+      </a:lnStyleLst>
+      <a:effectStyleLst>
+        <a:effectStyle>
+          <a:effectLst/>
+        </a:effectStyle>
+        <a:effectStyle>
+          <a:effectLst/>
+        </a:effectStyle>
+        <a:effectStyle>
+          <a:effectLst>
+            <a:outerShdw blurRad="57150" dist="19050" dir="5400000" algn="ctr" rotWithShape="0">
+              <a:srgbClr val="000000">
+                <a:alpha val="63000"/>
+              </a:srgbClr>
+            </a:outerShdw>
+          </a:effectLst>
+        </a:effectStyle>
+      </a:effectStyleLst>
+      <a:bgFillStyleLst>
+        <a:solidFill>
+          <a:schemeClr val="phClr"/>
+        </a:solidFill>
+        <a:solidFill>
+          <a:schemeClr val="phClr">
+            <a:tint val="95000"/>
+            <a:satMod val="170000"/>
+          </a:schemeClr>
+        </a:solidFill>
+        <a:gradFill rotWithShape="1">
+          <a:gsLst>
+            <a:gs pos="0">
+              <a:schemeClr val="phClr">
+                <a:tint val="93000"/>
+                <a:satMod val="150000"/>
+                <a:shade val="98000"/>
+                <a:lumMod val="102000"/>
+              </a:schemeClr>
+            </a:gs>
+            <a:gs pos="50000">
+              <a:schemeClr val="phClr">
+                <a:tint val="98000"/>
+                <a:satMod val="130000"/>
+                <a:shade val="90000"/>
+                <a:lumMod val="103000"/>
+              </a:schemeClr>
+            </a:gs>
+            <a:gs pos="100000">
+              <a:schemeClr val="phClr">
+                <a:shade val="63000"/>
+                <a:satMod val="120000"/>
+              </a:schemeClr>
+            </a:gs>
+          </a:gsLst>
+          <a:lin ang="5400000" scaled="0"/>
+        </a:gradFill>
+      </a:bgFillStyleLst>
+    </a:fmtScheme>
+  </a:themeElements>
+  <a:objectDefaults/>
+  <a:extraClrSchemeLst/>
+  <a:extLst>
+    <a:ext uri="{05A4C25C-085E-4340-85A3-A5531E510DB2}">
+      <thm15:themeFamily xmlns:thm15="http://schemas.microsoft.com/office/thememl/2012/main" name="Office Theme" id="{62F939B6-93AF-4DB8-9C6B-D6C7DFDC589F}" vid="{4A3C46E8-61CC-4603-A589-7422A47A8E4A}"/>
+    </a:ext>
+  </a:extLst>
+</a:theme>
 </file>
</xml_diff>